<commit_message>
Fix stale slide stats and surface scikit-learn usage
- Correct dataset numbers to 1,070 jobs / 153 candidates (was 77/26)
- Describe skills match as hybrid keyword + TF-IDF cosine (scikit-learn)
- Update limitations to reflect synthetic dataset and term-level matching
- Regenerate Final_Project_Presentation.pptx
</commit_message>
<xml_diff>
--- a/Final_Project_Presentation.pptx
+++ b/Final_Project_Presentation.pptx
@@ -723,12 +723,12 @@
           </a:p>
           <a:p>
             <a:r>
-              <a:t>1. Keyword matching – doesn’t understand React ≈ Vue. Solution: embeddings.</a:t>
-            </a:r>
-          </a:p>
-          <a:p>
-            <a:r>
-              <a:t>2. Small sample – 80 jobs, 25 candidates. Needs real databases.</a:t>
+              <a:t>1. Term matching – TF-IDF gives partial credit but not true synonyms (React ≈ Vue). Solution: embeddings.</a:t>
+            </a:r>
+          </a:p>
+          <a:p>
+            <a:r>
+              <a:t>2. Synthetic sample – 1,070 jobs, 153 candidates, all generated. Needs real databases.</a:t>
             </a:r>
           </a:p>
           <a:p>
@@ -1139,7 +1139,7 @@
           </a:p>
           <a:p>
             <a:r>
-              <a:t>Our dataset covers 77 jobs across major tech companies like Google, Meta, Amazon, OpenAI, and Anthropic, with 26 candidate profiles spanning backend, frontend, AI/ML, and DevOps roles.</a:t>
+              <a:t>Our dataset covers 1,070 jobs across major tech companies like Google, Meta, Amazon, OpenAI, and Anthropic, with 153 candidate profiles spanning backend, frontend, AI/ML, and DevOps roles.</a:t>
             </a:r>
           </a:p>
           <a:p>
@@ -1429,7 +1429,7 @@
           <a:p/>
           <a:p>
             <a:r>
-              <a:t>1. Skills Match (50%): intersection of candidate and required skills.</a:t>
+              <a:t>1. Skills Match (50%): hybrid score = exact keyword overlap, with a scikit-learn TF-IDF + cosine-similarity term filling the gap so related stacks earn partial credit.</a:t>
             </a:r>
           </a:p>
           <a:p>
@@ -5032,7 +5032,7 @@
         <p:spPr>
           <a:xfrm>
             <a:off x="5212080" y="320040"/>
-            <a:ext cx="2336292" cy="640080"/>
+            <a:ext cx="2423770" cy="640080"/>
           </a:xfrm>
           <a:prstGeom prst="rect">
             <a:avLst/>
@@ -5607,7 +5607,7 @@
         <p:spPr>
           <a:xfrm>
             <a:off x="10972800" y="182880"/>
-            <a:ext cx="1668780" cy="457200"/>
+            <a:ext cx="1731264" cy="457200"/>
           </a:xfrm>
           <a:prstGeom prst="rect">
             <a:avLst/>
@@ -7223,7 +7223,7 @@
         <p:spPr>
           <a:xfrm>
             <a:off x="10972800" y="182880"/>
-            <a:ext cx="1668780" cy="457200"/>
+            <a:ext cx="1731264" cy="457200"/>
           </a:xfrm>
           <a:prstGeom prst="rect">
             <a:avLst/>
@@ -7539,7 +7539,7 @@
               </a:defRPr>
             </a:pPr>
             <a:r>
-              <a:t>⚠  Keyword-Level Matching</a:t>
+              <a:t>⚠  Term-Level Matching</a:t>
             </a:r>
           </a:p>
         </p:txBody>
@@ -7575,11 +7575,11 @@
               </a:defRPr>
             </a:pPr>
             <a:r>
-              <a:t>Skills matching doesn’t recognize</a:t>
+              <a:t>TF-IDF captures shared context but not</a:t>
             </a:r>
             <a:br/>
             <a:r>
-              <a:t>React ↔ Vue as related frameworks</a:t>
+              <a:t>true synonyms (React ≈ Vue)</a:t>
             </a:r>
           </a:p>
         </p:txBody>
@@ -7705,7 +7705,7 @@
               </a:defRPr>
             </a:pPr>
             <a:r>
-              <a:t>⚠  Limited Sample Size</a:t>
+              <a:t>⚠  Synthetic Dataset</a:t>
             </a:r>
           </a:p>
         </p:txBody>
@@ -7741,7 +7741,7 @@
               </a:defRPr>
             </a:pPr>
             <a:r>
-              <a:t>Only ~80 jobs and ~25 candidates;</a:t>
+              <a:t>1,070 jobs / 153 candidates are generated;</a:t>
             </a:r>
             <a:br/>
             <a:r>
@@ -9551,7 +9551,7 @@
         <p:spPr>
           <a:xfrm>
             <a:off x="10972800" y="182880"/>
-            <a:ext cx="1668780" cy="457200"/>
+            <a:ext cx="1731264" cy="457200"/>
           </a:xfrm>
           <a:prstGeom prst="rect">
             <a:avLst/>
@@ -10723,7 +10723,7 @@
         <p:spPr>
           <a:xfrm>
             <a:off x="5212080" y="365760"/>
-            <a:ext cx="2169414" cy="594360"/>
+            <a:ext cx="2250643" cy="594360"/>
           </a:xfrm>
           <a:prstGeom prst="rect">
             <a:avLst/>
@@ -11301,7 +11301,7 @@
         <p:spPr>
           <a:xfrm>
             <a:off x="10972800" y="182880"/>
-            <a:ext cx="1668780" cy="457200"/>
+            <a:ext cx="1731264" cy="457200"/>
           </a:xfrm>
           <a:prstGeom prst="rect">
             <a:avLst/>
@@ -13183,7 +13183,7 @@
         <p:spPr>
           <a:xfrm>
             <a:off x="10972800" y="182880"/>
-            <a:ext cx="1668780" cy="457200"/>
+            <a:ext cx="1731264" cy="457200"/>
           </a:xfrm>
           <a:prstGeom prst="rect">
             <a:avLst/>
@@ -13968,7 +13968,7 @@
               </a:defRPr>
             </a:pPr>
             <a:r>
-              <a:t>• 77 job postings (LinkedIn-style)</a:t>
+              <a:t>• 1,070 job postings (LinkedIn-style)</a:t>
             </a:r>
           </a:p>
           <a:p>
@@ -13984,7 +13984,7 @@
               </a:defRPr>
             </a:pPr>
             <a:r>
-              <a:t>• 26 candidate profiles</a:t>
+              <a:t>• 153 candidate profiles</a:t>
             </a:r>
           </a:p>
           <a:p>
@@ -14558,7 +14558,7 @@
         <p:spPr>
           <a:xfrm>
             <a:off x="10972800" y="182880"/>
-            <a:ext cx="1668780" cy="457200"/>
+            <a:ext cx="1731264" cy="457200"/>
           </a:xfrm>
           <a:prstGeom prst="rect">
             <a:avLst/>
@@ -15888,7 +15888,7 @@
         <p:spPr>
           <a:xfrm>
             <a:off x="10972800" y="182880"/>
-            <a:ext cx="1668780" cy="457200"/>
+            <a:ext cx="1731264" cy="457200"/>
           </a:xfrm>
           <a:prstGeom prst="rect">
             <a:avLst/>
@@ -17372,7 +17372,7 @@
         <p:spPr>
           <a:xfrm>
             <a:off x="10972800" y="182880"/>
-            <a:ext cx="1668780" cy="457200"/>
+            <a:ext cx="1731264" cy="457200"/>
           </a:xfrm>
           <a:prstGeom prst="rect">
             <a:avLst/>
@@ -17804,11 +17804,11 @@
               </a:defRPr>
             </a:pPr>
             <a:r>
-              <a:t>|cand_skills ∩ job_skills|</a:t>
+              <a:t>keyword overlap + TF-IDF</a:t>
             </a:r>
             <a:br/>
             <a:r>
-              <a:t>/ |job_skills|</a:t>
+              <a:t>cosine similarity (scikit-learn)</a:t>
             </a:r>
           </a:p>
         </p:txBody>
@@ -17880,11 +17880,11 @@
               </a:defRPr>
             </a:pPr>
             <a:r>
-              <a:t>Keyword intersection ratio</a:t>
+              <a:t>Hybrid: exact keyword overlap,</a:t>
             </a:r>
             <a:br/>
             <a:r>
-              <a:t>of candidate vs. required skills</a:t>
+              <a:t>with TF-IDF cosine for related skills</a:t>
             </a:r>
           </a:p>
         </p:txBody>
@@ -19174,7 +19174,7 @@
         <p:spPr>
           <a:xfrm>
             <a:off x="10972800" y="182880"/>
-            <a:ext cx="1668780" cy="457200"/>
+            <a:ext cx="1731264" cy="457200"/>
           </a:xfrm>
           <a:prstGeom prst="rect">
             <a:avLst/>
@@ -20710,7 +20710,7 @@
               </a:defRPr>
             </a:pPr>
             <a:r>
-              <a:t>claude-opus-4-7 (configurable via LLM_MODEL env var)</a:t>
+              <a:t>claude-opus-4-8 (configurable via LLM_MODEL env var)</a:t>
             </a:r>
           </a:p>
         </p:txBody>
@@ -21062,7 +21062,7 @@
         <p:spPr>
           <a:xfrm>
             <a:off x="10972800" y="182880"/>
-            <a:ext cx="1668780" cy="457200"/>
+            <a:ext cx="1731264" cy="457200"/>
           </a:xfrm>
           <a:prstGeom prst="rect">
             <a:avLst/>
@@ -21381,7 +21381,7 @@
               </a:defRPr>
             </a:pPr>
             <a:r>
-              <a:t>•  Candidate selector dropdown (26 candidates)</a:t>
+              <a:t>•  Candidate selector dropdown (153 candidates)</a:t>
             </a:r>
           </a:p>
           <a:p>
@@ -21996,7 +21996,7 @@
               </a:defRPr>
             </a:pPr>
             <a:r>
-              <a:t>Anthropic Claude API (claude-opus-4-7)</a:t>
+              <a:t>Anthropic Claude API (claude-opus-4-8)</a:t>
             </a:r>
           </a:p>
         </p:txBody>
@@ -22348,7 +22348,7 @@
         <p:spPr>
           <a:xfrm>
             <a:off x="10972800" y="182880"/>
-            <a:ext cx="1668780" cy="457200"/>
+            <a:ext cx="1731264" cy="457200"/>
           </a:xfrm>
           <a:prstGeom prst="rect">
             <a:avLst/>

</xml_diff>

<commit_message>
Make university logo black and align it on slides
- Recolor white DUT wordmark to black (static/dut_logo_black.png) so it is
  visible on the light slide backgrounds
- Center the logo on title and closing slides; right-align it within the
  header band (was overflowing the slide's right edge)
- Regenerate Final_Project_Presentation.pptx
</commit_message>
<xml_diff>
--- a/Final_Project_Presentation.pptx
+++ b/Final_Project_Presentation.pptx
@@ -5017,7 +5017,7 @@
       </p:sp>
       <p:pic>
         <p:nvPicPr>
-          <p:cNvPr id="7" name="Picture 6" descr="dut_logo.png"/>
+          <p:cNvPr id="7" name="Picture 6" descr="dut_logo_black.png"/>
           <p:cNvPicPr>
             <a:picLocks noChangeAspect="1"/>
           </p:cNvPicPr>
@@ -5031,7 +5031,7 @@
         </p:blipFill>
         <p:spPr>
           <a:xfrm>
-            <a:off x="5212080" y="320040"/>
+            <a:off x="4883962" y="320040"/>
             <a:ext cx="2423770" cy="640080"/>
           </a:xfrm>
           <a:prstGeom prst="rect">
@@ -5592,7 +5592,7 @@
       </p:sp>
       <p:pic>
         <p:nvPicPr>
-          <p:cNvPr id="6" name="Picture 5" descr="dut_logo.png"/>
+          <p:cNvPr id="6" name="Picture 5" descr="dut_logo_black.png"/>
           <p:cNvPicPr>
             <a:picLocks noChangeAspect="1"/>
           </p:cNvPicPr>
@@ -5606,8 +5606,8 @@
         </p:blipFill>
         <p:spPr>
           <a:xfrm>
-            <a:off x="10972800" y="182880"/>
-            <a:ext cx="1731264" cy="457200"/>
+            <a:off x="10371673" y="292608"/>
+            <a:ext cx="1454262" cy="384048"/>
           </a:xfrm>
           <a:prstGeom prst="rect">
             <a:avLst/>
@@ -7208,7 +7208,7 @@
       </p:sp>
       <p:pic>
         <p:nvPicPr>
-          <p:cNvPr id="6" name="Picture 5" descr="dut_logo.png"/>
+          <p:cNvPr id="6" name="Picture 5" descr="dut_logo_black.png"/>
           <p:cNvPicPr>
             <a:picLocks noChangeAspect="1"/>
           </p:cNvPicPr>
@@ -7222,8 +7222,8 @@
         </p:blipFill>
         <p:spPr>
           <a:xfrm>
-            <a:off x="10972800" y="182880"/>
-            <a:ext cx="1731264" cy="457200"/>
+            <a:off x="10371673" y="292608"/>
+            <a:ext cx="1454262" cy="384048"/>
           </a:xfrm>
           <a:prstGeom prst="rect">
             <a:avLst/>
@@ -9536,7 +9536,7 @@
       </p:sp>
       <p:pic>
         <p:nvPicPr>
-          <p:cNvPr id="6" name="Picture 5" descr="dut_logo.png"/>
+          <p:cNvPr id="6" name="Picture 5" descr="dut_logo_black.png"/>
           <p:cNvPicPr>
             <a:picLocks noChangeAspect="1"/>
           </p:cNvPicPr>
@@ -9550,8 +9550,8 @@
         </p:blipFill>
         <p:spPr>
           <a:xfrm>
-            <a:off x="10972800" y="182880"/>
-            <a:ext cx="1731264" cy="457200"/>
+            <a:off x="10371673" y="292608"/>
+            <a:ext cx="1454262" cy="384048"/>
           </a:xfrm>
           <a:prstGeom prst="rect">
             <a:avLst/>
@@ -10708,7 +10708,7 @@
       </p:sp>
       <p:pic>
         <p:nvPicPr>
-          <p:cNvPr id="7" name="Picture 6" descr="dut_logo.png"/>
+          <p:cNvPr id="7" name="Picture 6" descr="dut_logo_black.png"/>
           <p:cNvPicPr>
             <a:picLocks noChangeAspect="1"/>
           </p:cNvPicPr>
@@ -10722,7 +10722,7 @@
         </p:blipFill>
         <p:spPr>
           <a:xfrm>
-            <a:off x="5212080" y="365760"/>
+            <a:off x="4970526" y="365760"/>
             <a:ext cx="2250643" cy="594360"/>
           </a:xfrm>
           <a:prstGeom prst="rect">
@@ -11286,7 +11286,7 @@
       </p:sp>
       <p:pic>
         <p:nvPicPr>
-          <p:cNvPr id="5" name="Picture 4" descr="dut_logo.png"/>
+          <p:cNvPr id="5" name="Picture 4" descr="dut_logo_black.png"/>
           <p:cNvPicPr>
             <a:picLocks noChangeAspect="1"/>
           </p:cNvPicPr>
@@ -11300,8 +11300,8 @@
         </p:blipFill>
         <p:spPr>
           <a:xfrm>
-            <a:off x="10972800" y="182880"/>
-            <a:ext cx="1731264" cy="457200"/>
+            <a:off x="10371673" y="292608"/>
+            <a:ext cx="1454262" cy="384048"/>
           </a:xfrm>
           <a:prstGeom prst="rect">
             <a:avLst/>
@@ -13168,7 +13168,7 @@
       </p:sp>
       <p:pic>
         <p:nvPicPr>
-          <p:cNvPr id="6" name="Picture 5" descr="dut_logo.png"/>
+          <p:cNvPr id="6" name="Picture 5" descr="dut_logo_black.png"/>
           <p:cNvPicPr>
             <a:picLocks noChangeAspect="1"/>
           </p:cNvPicPr>
@@ -13182,8 +13182,8 @@
         </p:blipFill>
         <p:spPr>
           <a:xfrm>
-            <a:off x="10972800" y="182880"/>
-            <a:ext cx="1731264" cy="457200"/>
+            <a:off x="10371673" y="292608"/>
+            <a:ext cx="1454262" cy="384048"/>
           </a:xfrm>
           <a:prstGeom prst="rect">
             <a:avLst/>
@@ -14543,7 +14543,7 @@
       </p:sp>
       <p:pic>
         <p:nvPicPr>
-          <p:cNvPr id="6" name="Picture 5" descr="dut_logo.png"/>
+          <p:cNvPr id="6" name="Picture 5" descr="dut_logo_black.png"/>
           <p:cNvPicPr>
             <a:picLocks noChangeAspect="1"/>
           </p:cNvPicPr>
@@ -14557,8 +14557,8 @@
         </p:blipFill>
         <p:spPr>
           <a:xfrm>
-            <a:off x="10972800" y="182880"/>
-            <a:ext cx="1731264" cy="457200"/>
+            <a:off x="10371673" y="292608"/>
+            <a:ext cx="1454262" cy="384048"/>
           </a:xfrm>
           <a:prstGeom prst="rect">
             <a:avLst/>
@@ -15873,7 +15873,7 @@
       </p:sp>
       <p:pic>
         <p:nvPicPr>
-          <p:cNvPr id="6" name="Picture 5" descr="dut_logo.png"/>
+          <p:cNvPr id="6" name="Picture 5" descr="dut_logo_black.png"/>
           <p:cNvPicPr>
             <a:picLocks noChangeAspect="1"/>
           </p:cNvPicPr>
@@ -15887,8 +15887,8 @@
         </p:blipFill>
         <p:spPr>
           <a:xfrm>
-            <a:off x="10972800" y="182880"/>
-            <a:ext cx="1731264" cy="457200"/>
+            <a:off x="10371673" y="292608"/>
+            <a:ext cx="1454262" cy="384048"/>
           </a:xfrm>
           <a:prstGeom prst="rect">
             <a:avLst/>
@@ -17357,7 +17357,7 @@
       </p:sp>
       <p:pic>
         <p:nvPicPr>
-          <p:cNvPr id="6" name="Picture 5" descr="dut_logo.png"/>
+          <p:cNvPr id="6" name="Picture 5" descr="dut_logo_black.png"/>
           <p:cNvPicPr>
             <a:picLocks noChangeAspect="1"/>
           </p:cNvPicPr>
@@ -17371,8 +17371,8 @@
         </p:blipFill>
         <p:spPr>
           <a:xfrm>
-            <a:off x="10972800" y="182880"/>
-            <a:ext cx="1731264" cy="457200"/>
+            <a:off x="10371673" y="292608"/>
+            <a:ext cx="1454262" cy="384048"/>
           </a:xfrm>
           <a:prstGeom prst="rect">
             <a:avLst/>
@@ -19159,7 +19159,7 @@
       </p:sp>
       <p:pic>
         <p:nvPicPr>
-          <p:cNvPr id="6" name="Picture 5" descr="dut_logo.png"/>
+          <p:cNvPr id="6" name="Picture 5" descr="dut_logo_black.png"/>
           <p:cNvPicPr>
             <a:picLocks noChangeAspect="1"/>
           </p:cNvPicPr>
@@ -19173,8 +19173,8 @@
         </p:blipFill>
         <p:spPr>
           <a:xfrm>
-            <a:off x="10972800" y="182880"/>
-            <a:ext cx="1731264" cy="457200"/>
+            <a:off x="10371673" y="292608"/>
+            <a:ext cx="1454262" cy="384048"/>
           </a:xfrm>
           <a:prstGeom prst="rect">
             <a:avLst/>
@@ -21047,7 +21047,7 @@
       </p:sp>
       <p:pic>
         <p:nvPicPr>
-          <p:cNvPr id="6" name="Picture 5" descr="dut_logo.png"/>
+          <p:cNvPr id="6" name="Picture 5" descr="dut_logo_black.png"/>
           <p:cNvPicPr>
             <a:picLocks noChangeAspect="1"/>
           </p:cNvPicPr>
@@ -21061,8 +21061,8 @@
         </p:blipFill>
         <p:spPr>
           <a:xfrm>
-            <a:off x="10972800" y="182880"/>
-            <a:ext cx="1731264" cy="457200"/>
+            <a:off x="10371673" y="292608"/>
+            <a:ext cx="1454262" cy="384048"/>
           </a:xfrm>
           <a:prstGeom prst="rect">
             <a:avLst/>
@@ -22333,7 +22333,7 @@
       </p:sp>
       <p:pic>
         <p:nvPicPr>
-          <p:cNvPr id="6" name="Picture 5" descr="dut_logo.png"/>
+          <p:cNvPr id="6" name="Picture 5" descr="dut_logo_black.png"/>
           <p:cNvPicPr>
             <a:picLocks noChangeAspect="1"/>
           </p:cNvPicPr>
@@ -22347,8 +22347,8 @@
         </p:blipFill>
         <p:spPr>
           <a:xfrm>
-            <a:off x="10972800" y="182880"/>
-            <a:ext cx="1731264" cy="457200"/>
+            <a:off x="10371673" y="292608"/>
+            <a:ext cx="1454262" cy="384048"/>
           </a:xfrm>
           <a:prstGeom prst="rect">
             <a:avLst/>

</xml_diff>

<commit_message>
Switch LLM provider from Anthropic Claude to Qwen (DashScope)
- Notebook uses the openai SDK against the OpenAI-compatible DashScope
  endpoint; llm_explain_match now calls chat.completions (mock fallback kept)
- requirements: anthropic -> openai
- .env/.env.example: DASHSCOPE_API_KEY + LLM_BASE_URL + LLM_MODEL (qwen-plus)
- Scrub Claude/Anthropic references from notebook, README, and slides
- Regenerate Final_Project_Presentation.pptx
- Ignore PowerPoint ~$ lock files
</commit_message>
<xml_diff>
--- a/Final_Project_Presentation.pptx
+++ b/Final_Project_Presentation.pptx
@@ -535,7 +535,7 @@
           </a:p>
           <a:p>
             <a:r>
-              <a:t>My project is an LLM-Powered Intelligent Job Matching System that combines rule-based scoring with Claude AI to help HR teams match candidates to job postings.</a:t>
+              <a:t>My project is an LLM-Powered Intelligent Job Matching System that combines rule-based scoring with Qwen to help HR teams match candidates to job postings.</a:t>
             </a:r>
           </a:p>
           <a:p>
@@ -636,7 +636,7 @@
           </a:p>
           <a:p>
             <a:r>
-              <a:t>4. AI-powered explanations via Claude</a:t>
+              <a:t>4. AI-powered explanations via Qwen</a:t>
             </a:r>
           </a:p>
           <a:p/>
@@ -946,7 +946,7 @@
           </a:p>
           <a:p>
             <a:r>
-              <a:t>3. Add your Anthropic API key to .env</a:t>
+              <a:t>3. Add your DashScope API key to .env</a:t>
             </a:r>
           </a:p>
           <a:p>
@@ -1331,7 +1331,7 @@
           </a:p>
           <a:p>
             <a:r>
-              <a:t>Layer 2: LLM (Claude) generates natural-language explanations for the top match.</a:t>
+              <a:t>Layer 2: LLM (Qwen) generates natural-language explanations for the top match.</a:t>
             </a:r>
           </a:p>
           <a:p/>
@@ -1450,7 +1450,7 @@
           <a:p/>
           <a:p>
             <a:r>
-              <a:t>The 0.3 for location mismatch was suggested by Claude to preserve remote options.</a:t>
+              <a:t>The 0.3 for location mismatch was suggested by Qwen to preserve remote options.</a:t>
             </a:r>
           </a:p>
           <a:p>
@@ -1531,7 +1531,7 @@
           <a:p/>
           <a:p>
             <a:r>
-              <a:t>Claude is used throughout the project lifecycle, not just at runtime:</a:t>
+              <a:t>Qwen is used throughout the project lifecycle, not just at runtime:</a:t>
             </a:r>
           </a:p>
           <a:p>
@@ -1669,7 +1669,7 @@
           <a:p/>
           <a:p>
             <a:r>
-              <a:t>Tech stack: Python (pandas, numpy, scikit-learn, matplotlib), Anthropic Claude API, ipywidgets + Flask.</a:t>
+              <a:t>Tech stack: Python (pandas, numpy, scikit-learn, matplotlib), Qwen (DashScope) API, ipywidgets + Flask.</a:t>
             </a:r>
           </a:p>
         </p:txBody>
@@ -1770,7 +1770,7 @@
           </a:p>
           <a:p>
             <a:r>
-              <a:t>5. Show Claude AI analysis – highlights/gaps/recommendation.</a:t>
+              <a:t>5. Show Qwen analysis – highlights/gaps/recommendation.</a:t>
             </a:r>
           </a:p>
           <a:p>
@@ -6441,7 +6441,7 @@
             </a:r>
             <a:br/>
             <a:r>
-              <a:t>rationale via Claude</a:t>
+              <a:t>rationale via Qwen</a:t>
             </a:r>
           </a:p>
         </p:txBody>
@@ -10447,7 +10447,7 @@
               </a:defRPr>
             </a:pPr>
             <a:r>
-              <a:t>Claude is used across the full project lifecycle: design, coding,</a:t>
+              <a:t>Qwen is used across the full project lifecycle: design, coding,</a:t>
             </a:r>
             <a:br/>
             <a:r>
@@ -12215,7 +12215,7 @@
               </a:defRPr>
             </a:pPr>
             <a:r>
-              <a:t>How Claude enhances the system</a:t>
+              <a:t>How Qwen enhances the system</a:t>
             </a:r>
           </a:p>
         </p:txBody>
@@ -16626,7 +16626,7 @@
               </a:defRPr>
             </a:pPr>
             <a:r>
-              <a:t>Claude Analysis</a:t>
+              <a:t>Qwen Analysis</a:t>
             </a:r>
             <a:br/>
             <a:r>
@@ -19152,7 +19152,7 @@
               </a:defRPr>
             </a:pPr>
             <a:r>
-              <a:t>Claude API for semantic analysis and natural-language recommendations</a:t>
+              <a:t>Qwen API for semantic analysis and natural-language recommendations</a:t>
             </a:r>
           </a:p>
         </p:txBody>
@@ -20710,7 +20710,7 @@
               </a:defRPr>
             </a:pPr>
             <a:r>
-              <a:t>claude-opus-4-8 (configurable via LLM_MODEL env var)</a:t>
+              <a:t>qwen-plus (configurable via LLM_MODEL env var)</a:t>
             </a:r>
           </a:p>
         </p:txBody>
@@ -21509,7 +21509,7 @@
               </a:defRPr>
             </a:pPr>
             <a:r>
-              <a:t>•  LLM analysis toggle (enable/disable Claude)</a:t>
+              <a:t>•  LLM analysis toggle (enable/disable Qwen)</a:t>
             </a:r>
           </a:p>
         </p:txBody>
@@ -21754,7 +21754,7 @@
               </a:defRPr>
             </a:pPr>
             <a:r>
-              <a:t>•  Claude AI analysis on demand</a:t>
+              <a:t>•  Qwen analysis on demand</a:t>
             </a:r>
           </a:p>
           <a:p>
@@ -21996,7 +21996,7 @@
               </a:defRPr>
             </a:pPr>
             <a:r>
-              <a:t>Anthropic Claude API (claude-opus-4-8)</a:t>
+              <a:t>Qwen (DashScope) API (qwen-plus)</a:t>
             </a:r>
           </a:p>
         </p:txBody>
@@ -23644,7 +23644,7 @@
               </a:defRPr>
             </a:pPr>
             <a:r>
-              <a:t>Show Claude-generated explanation</a:t>
+              <a:t>Show Qwen-generated explanation</a:t>
             </a:r>
           </a:p>
         </p:txBody>

</xml_diff>

<commit_message>
Trim slide 10 to the requirements checklist
- Remove the 4 redundant capability cards (repeated slides 5/6/8)
- Enlarge the Assignment Requirements Checklist as the slide's focus
- Add a row for the verified live Qwen LLM analysis
- Reframe presenter notes as a recap, not self-grading
</commit_message>
<xml_diff>
--- a/Final_Project_Presentation.pptx
+++ b/Final_Project_Presentation.pptx
@@ -616,33 +616,24 @@
           <a:p/>
           <a:p>
             <a:r>
-              <a:t>Four key capabilities:</a:t>
-            </a:r>
-          </a:p>
-          <a:p>
-            <a:r>
-              <a:t>1. Quantitative matching across 4 dimensions with adjustable weights</a:t>
-            </a:r>
-          </a:p>
-          <a:p>
-            <a:r>
-              <a:t>2. Dual-view visualization: bar charts and global heatmap</a:t>
-            </a:r>
-          </a:p>
-          <a:p>
-            <a:r>
-              <a:t>3. Live interactivity with 9 controls</a:t>
-            </a:r>
-          </a:p>
-          <a:p>
-            <a:r>
-              <a:t>4. AI-powered explanations via Qwen</a:t>
+              <a:t>To summarize, here is how the project maps to each official requirement.</a:t>
+            </a:r>
+          </a:p>
+          <a:p>
+            <a:r>
+              <a:t>(Frame this as a recap, not self-grading.)</a:t>
             </a:r>
           </a:p>
           <a:p/>
           <a:p>
             <a:r>
-              <a:t>All five assignment requirements are met — complete pipeline, Python + Jupyter, required libraries, all four modules, and fully runnable code.</a:t>
+              <a:t>Every requirement is met: complete input-&gt;analysis-&gt;display-&gt;recommendation pipeline, Python + Jupyter Notebook, all required libraries (pandas, matplotlib, scikit-learn, ipywidgets), all four modules with 9 interactive controls, fully runnable end-to-end, and a live LLM (Qwen) analysis I verified is working.</a:t>
+            </a:r>
+          </a:p>
+          <a:p/>
+          <a:p>
+            <a:r>
+              <a:t>Pause on the last row — the live Qwen call is the core deliverable and it runs in the demo.</a:t>
             </a:r>
           </a:p>
         </p:txBody>
@@ -5768,14 +5759,86 @@
       </p:sp>
       <p:sp>
         <p:nvSpPr>
-          <p:cNvPr id="11" name="Rounded Rectangle 10"/>
+          <p:cNvPr id="11" name="TextBox 10"/>
+          <p:cNvSpPr txBox="1"/>
+          <p:nvPr/>
+        </p:nvSpPr>
+        <p:spPr>
+          <a:xfrm>
+            <a:off x="731520" y="1554480"/>
+            <a:ext cx="10728655" cy="411480"/>
+          </a:xfrm>
+          <a:prstGeom prst="rect">
+            <a:avLst/>
+          </a:prstGeom>
+          <a:noFill/>
+        </p:spPr>
+        <p:txBody>
+          <a:bodyPr wrap="square">
+            <a:spAutoFit/>
+          </a:bodyPr>
+          <a:lstStyle/>
+          <a:p>
+            <a:pPr algn="l">
+              <a:defRPr sz="2400" b="1" i="0">
+                <a:solidFill>
+                  <a:srgbClr val="0F3DA8"/>
+                </a:solidFill>
+                <a:latin typeface="Calibri"/>
+              </a:defRPr>
+            </a:pPr>
+            <a:r>
+              <a:t>Assignment Requirements Checklist</a:t>
+            </a:r>
+          </a:p>
+        </p:txBody>
+      </p:sp>
+      <p:sp>
+        <p:nvSpPr>
+          <p:cNvPr id="12" name="TextBox 11"/>
+          <p:cNvSpPr txBox="1"/>
+          <p:nvPr/>
+        </p:nvSpPr>
+        <p:spPr>
+          <a:xfrm>
+            <a:off x="731520" y="2148840"/>
+            <a:ext cx="10728655" cy="320040"/>
+          </a:xfrm>
+          <a:prstGeom prst="rect">
+            <a:avLst/>
+          </a:prstGeom>
+          <a:noFill/>
+        </p:spPr>
+        <p:txBody>
+          <a:bodyPr wrap="square">
+            <a:spAutoFit/>
+          </a:bodyPr>
+          <a:lstStyle/>
+          <a:p>
+            <a:pPr algn="l">
+              <a:defRPr sz="1400" b="0" i="1">
+                <a:solidFill>
+                  <a:srgbClr val="4A5A6A"/>
+                </a:solidFill>
+                <a:latin typeface="Calibri"/>
+              </a:defRPr>
+            </a:pPr>
+            <a:r>
+              <a:t>How the project maps to each official requirement</a:t>
+            </a:r>
+          </a:p>
+        </p:txBody>
+      </p:sp>
+      <p:sp>
+        <p:nvSpPr>
+          <p:cNvPr id="13" name="Rounded Rectangle 12"/>
           <p:cNvSpPr/>
           <p:nvPr/>
         </p:nvSpPr>
         <p:spPr>
           <a:xfrm>
-            <a:off x="548640" y="1325880"/>
-            <a:ext cx="2697480" cy="1965960"/>
+            <a:off x="731520" y="2697480"/>
+            <a:ext cx="10728655" cy="3246120"/>
           </a:xfrm>
           <a:prstGeom prst="roundRect">
             <a:avLst/>
@@ -5814,730 +5877,14 @@
       </p:sp>
       <p:sp>
         <p:nvSpPr>
-          <p:cNvPr id="12" name="Rectangle 11"/>
+          <p:cNvPr id="14" name="Rounded Rectangle 13"/>
           <p:cNvSpPr/>
           <p:nvPr/>
         </p:nvSpPr>
         <p:spPr>
           <a:xfrm>
-            <a:off x="548640" y="1325880"/>
-            <a:ext cx="2697480" cy="640080"/>
-          </a:xfrm>
-          <a:prstGeom prst="rect">
-            <a:avLst/>
-          </a:prstGeom>
-          <a:solidFill>
-            <a:srgbClr val="1A56DB"/>
-          </a:solidFill>
-          <a:ln>
-            <a:noFill/>
-          </a:ln>
-          <a:effectLst/>
-        </p:spPr>
-        <p:style>
-          <a:lnRef idx="1">
-            <a:schemeClr val="accent1"/>
-          </a:lnRef>
-          <a:fillRef idx="3">
-            <a:schemeClr val="accent1"/>
-          </a:fillRef>
-          <a:effectRef idx="2">
-            <a:schemeClr val="accent1"/>
-          </a:effectRef>
-          <a:fontRef idx="minor">
-            <a:schemeClr val="lt1"/>
-          </a:fontRef>
-        </p:style>
-        <p:txBody>
-          <a:bodyPr rtlCol="0" anchor="ctr"/>
-          <a:lstStyle/>
-          <a:p>
-            <a:pPr algn="ctr"/>
-          </a:p>
-        </p:txBody>
-      </p:sp>
-      <p:sp>
-        <p:nvSpPr>
-          <p:cNvPr id="13" name="TextBox 12"/>
-          <p:cNvSpPr txBox="1"/>
-          <p:nvPr/>
-        </p:nvSpPr>
-        <p:spPr>
-          <a:xfrm>
-            <a:off x="685800" y="1371600"/>
-            <a:ext cx="2423160" cy="548640"/>
-          </a:xfrm>
-          <a:prstGeom prst="rect">
-            <a:avLst/>
-          </a:prstGeom>
-          <a:noFill/>
-        </p:spPr>
-        <p:txBody>
-          <a:bodyPr wrap="square">
-            <a:spAutoFit/>
-          </a:bodyPr>
-          <a:lstStyle/>
-          <a:p>
-            <a:pPr algn="ctr">
-              <a:defRPr sz="1500" b="1" i="0">
-                <a:solidFill>
-                  <a:srgbClr val="FFFFFF"/>
-                </a:solidFill>
-                <a:latin typeface="Calibri"/>
-              </a:defRPr>
-            </a:pPr>
-            <a:r>
-              <a:t>Quantitative</a:t>
-            </a:r>
-            <a:br/>
-            <a:r>
-              <a:t>Matching</a:t>
-            </a:r>
-          </a:p>
-        </p:txBody>
-      </p:sp>
-      <p:sp>
-        <p:nvSpPr>
-          <p:cNvPr id="14" name="TextBox 13"/>
-          <p:cNvSpPr txBox="1"/>
-          <p:nvPr/>
-        </p:nvSpPr>
-        <p:spPr>
-          <a:xfrm>
-            <a:off x="685800" y="2103120"/>
-            <a:ext cx="2423160" cy="914400"/>
-          </a:xfrm>
-          <a:prstGeom prst="rect">
-            <a:avLst/>
-          </a:prstGeom>
-          <a:noFill/>
-        </p:spPr>
-        <p:txBody>
-          <a:bodyPr wrap="square">
-            <a:spAutoFit/>
-          </a:bodyPr>
-          <a:lstStyle/>
-          <a:p>
-            <a:pPr algn="ctr">
-              <a:defRPr sz="1300" b="0" i="0">
-                <a:solidFill>
-                  <a:srgbClr val="4A5A6A"/>
-                </a:solidFill>
-                <a:latin typeface="Calibri"/>
-              </a:defRPr>
-            </a:pPr>
-            <a:r>
-              <a:t>4-dimension weighted scoring</a:t>
-            </a:r>
-            <a:br/>
-            <a:r>
-              <a:t>with auto-normalization</a:t>
-            </a:r>
-          </a:p>
-        </p:txBody>
-      </p:sp>
-      <p:sp>
-        <p:nvSpPr>
-          <p:cNvPr id="15" name="Rounded Rectangle 14"/>
-          <p:cNvSpPr/>
-          <p:nvPr/>
-        </p:nvSpPr>
-        <p:spPr>
-          <a:xfrm>
-            <a:off x="3429000" y="1325880"/>
-            <a:ext cx="2697480" cy="1965960"/>
-          </a:xfrm>
-          <a:prstGeom prst="roundRect">
-            <a:avLst/>
-          </a:prstGeom>
-          <a:solidFill>
-            <a:srgbClr val="FFFFFF"/>
-          </a:solidFill>
-          <a:ln w="9525">
-            <a:solidFill>
-              <a:srgbClr val="E0E0E0"/>
-            </a:solidFill>
-          </a:ln>
-          <a:effectLst/>
-        </p:spPr>
-        <p:style>
-          <a:lnRef idx="1">
-            <a:schemeClr val="accent1"/>
-          </a:lnRef>
-          <a:fillRef idx="3">
-            <a:schemeClr val="accent1"/>
-          </a:fillRef>
-          <a:effectRef idx="2">
-            <a:schemeClr val="accent1"/>
-          </a:effectRef>
-          <a:fontRef idx="minor">
-            <a:schemeClr val="lt1"/>
-          </a:fontRef>
-        </p:style>
-        <p:txBody>
-          <a:bodyPr rtlCol="0" anchor="ctr"/>
-          <a:lstStyle/>
-          <a:p>
-            <a:pPr algn="ctr"/>
-          </a:p>
-        </p:txBody>
-      </p:sp>
-      <p:sp>
-        <p:nvSpPr>
-          <p:cNvPr id="16" name="Rectangle 15"/>
-          <p:cNvSpPr/>
-          <p:nvPr/>
-        </p:nvSpPr>
-        <p:spPr>
-          <a:xfrm>
-            <a:off x="3429000" y="1325880"/>
-            <a:ext cx="2697480" cy="640080"/>
-          </a:xfrm>
-          <a:prstGeom prst="rect">
-            <a:avLst/>
-          </a:prstGeom>
-          <a:solidFill>
-            <a:srgbClr val="00897B"/>
-          </a:solidFill>
-          <a:ln>
-            <a:noFill/>
-          </a:ln>
-          <a:effectLst/>
-        </p:spPr>
-        <p:style>
-          <a:lnRef idx="1">
-            <a:schemeClr val="accent1"/>
-          </a:lnRef>
-          <a:fillRef idx="3">
-            <a:schemeClr val="accent1"/>
-          </a:fillRef>
-          <a:effectRef idx="2">
-            <a:schemeClr val="accent1"/>
-          </a:effectRef>
-          <a:fontRef idx="minor">
-            <a:schemeClr val="lt1"/>
-          </a:fontRef>
-        </p:style>
-        <p:txBody>
-          <a:bodyPr rtlCol="0" anchor="ctr"/>
-          <a:lstStyle/>
-          <a:p>
-            <a:pPr algn="ctr"/>
-          </a:p>
-        </p:txBody>
-      </p:sp>
-      <p:sp>
-        <p:nvSpPr>
-          <p:cNvPr id="17" name="TextBox 16"/>
-          <p:cNvSpPr txBox="1"/>
-          <p:nvPr/>
-        </p:nvSpPr>
-        <p:spPr>
-          <a:xfrm>
-            <a:off x="3566160" y="1371600"/>
-            <a:ext cx="2423160" cy="548640"/>
-          </a:xfrm>
-          <a:prstGeom prst="rect">
-            <a:avLst/>
-          </a:prstGeom>
-          <a:noFill/>
-        </p:spPr>
-        <p:txBody>
-          <a:bodyPr wrap="square">
-            <a:spAutoFit/>
-          </a:bodyPr>
-          <a:lstStyle/>
-          <a:p>
-            <a:pPr algn="ctr">
-              <a:defRPr sz="1500" b="1" i="0">
-                <a:solidFill>
-                  <a:srgbClr val="FFFFFF"/>
-                </a:solidFill>
-                <a:latin typeface="Calibri"/>
-              </a:defRPr>
-            </a:pPr>
-            <a:r>
-              <a:t>Clean</a:t>
-            </a:r>
-            <a:br/>
-            <a:r>
-              <a:t>Visualization</a:t>
-            </a:r>
-          </a:p>
-        </p:txBody>
-      </p:sp>
-      <p:sp>
-        <p:nvSpPr>
-          <p:cNvPr id="18" name="TextBox 17"/>
-          <p:cNvSpPr txBox="1"/>
-          <p:nvPr/>
-        </p:nvSpPr>
-        <p:spPr>
-          <a:xfrm>
-            <a:off x="3566160" y="2103120"/>
-            <a:ext cx="2423160" cy="914400"/>
-          </a:xfrm>
-          <a:prstGeom prst="rect">
-            <a:avLst/>
-          </a:prstGeom>
-          <a:noFill/>
-        </p:spPr>
-        <p:txBody>
-          <a:bodyPr wrap="square">
-            <a:spAutoFit/>
-          </a:bodyPr>
-          <a:lstStyle/>
-          <a:p>
-            <a:pPr algn="ctr">
-              <a:defRPr sz="1300" b="0" i="0">
-                <a:solidFill>
-                  <a:srgbClr val="4A5A6A"/>
-                </a:solidFill>
-                <a:latin typeface="Calibri"/>
-              </a:defRPr>
-            </a:pPr>
-            <a:r>
-              <a:t>Dual bar charts (total +</a:t>
-            </a:r>
-            <a:br/>
-            <a:r>
-              <a:t>breakdown) + global heatmap</a:t>
-            </a:r>
-          </a:p>
-        </p:txBody>
-      </p:sp>
-      <p:sp>
-        <p:nvSpPr>
-          <p:cNvPr id="19" name="Rounded Rectangle 18"/>
-          <p:cNvSpPr/>
-          <p:nvPr/>
-        </p:nvSpPr>
-        <p:spPr>
-          <a:xfrm>
-            <a:off x="6309359" y="1325880"/>
-            <a:ext cx="2697480" cy="1965960"/>
-          </a:xfrm>
-          <a:prstGeom prst="roundRect">
-            <a:avLst/>
-          </a:prstGeom>
-          <a:solidFill>
-            <a:srgbClr val="FFFFFF"/>
-          </a:solidFill>
-          <a:ln w="9525">
-            <a:solidFill>
-              <a:srgbClr val="E0E0E0"/>
-            </a:solidFill>
-          </a:ln>
-          <a:effectLst/>
-        </p:spPr>
-        <p:style>
-          <a:lnRef idx="1">
-            <a:schemeClr val="accent1"/>
-          </a:lnRef>
-          <a:fillRef idx="3">
-            <a:schemeClr val="accent1"/>
-          </a:fillRef>
-          <a:effectRef idx="2">
-            <a:schemeClr val="accent1"/>
-          </a:effectRef>
-          <a:fontRef idx="minor">
-            <a:schemeClr val="lt1"/>
-          </a:fontRef>
-        </p:style>
-        <p:txBody>
-          <a:bodyPr rtlCol="0" anchor="ctr"/>
-          <a:lstStyle/>
-          <a:p>
-            <a:pPr algn="ctr"/>
-          </a:p>
-        </p:txBody>
-      </p:sp>
-      <p:sp>
-        <p:nvSpPr>
-          <p:cNvPr id="20" name="Rectangle 19"/>
-          <p:cNvSpPr/>
-          <p:nvPr/>
-        </p:nvSpPr>
-        <p:spPr>
-          <a:xfrm>
-            <a:off x="6309359" y="1325880"/>
-            <a:ext cx="2697480" cy="640080"/>
-          </a:xfrm>
-          <a:prstGeom prst="rect">
-            <a:avLst/>
-          </a:prstGeom>
-          <a:solidFill>
-            <a:srgbClr val="2E7D32"/>
-          </a:solidFill>
-          <a:ln>
-            <a:noFill/>
-          </a:ln>
-          <a:effectLst/>
-        </p:spPr>
-        <p:style>
-          <a:lnRef idx="1">
-            <a:schemeClr val="accent1"/>
-          </a:lnRef>
-          <a:fillRef idx="3">
-            <a:schemeClr val="accent1"/>
-          </a:fillRef>
-          <a:effectRef idx="2">
-            <a:schemeClr val="accent1"/>
-          </a:effectRef>
-          <a:fontRef idx="minor">
-            <a:schemeClr val="lt1"/>
-          </a:fontRef>
-        </p:style>
-        <p:txBody>
-          <a:bodyPr rtlCol="0" anchor="ctr"/>
-          <a:lstStyle/>
-          <a:p>
-            <a:pPr algn="ctr"/>
-          </a:p>
-        </p:txBody>
-      </p:sp>
-      <p:sp>
-        <p:nvSpPr>
-          <p:cNvPr id="21" name="TextBox 20"/>
-          <p:cNvSpPr txBox="1"/>
-          <p:nvPr/>
-        </p:nvSpPr>
-        <p:spPr>
-          <a:xfrm>
-            <a:off x="6446519" y="1371600"/>
-            <a:ext cx="2423160" cy="548640"/>
-          </a:xfrm>
-          <a:prstGeom prst="rect">
-            <a:avLst/>
-          </a:prstGeom>
-          <a:noFill/>
-        </p:spPr>
-        <p:txBody>
-          <a:bodyPr wrap="square">
-            <a:spAutoFit/>
-          </a:bodyPr>
-          <a:lstStyle/>
-          <a:p>
-            <a:pPr algn="ctr">
-              <a:defRPr sz="1500" b="1" i="0">
-                <a:solidFill>
-                  <a:srgbClr val="FFFFFF"/>
-                </a:solidFill>
-                <a:latin typeface="Calibri"/>
-              </a:defRPr>
-            </a:pPr>
-            <a:r>
-              <a:t>Live</a:t>
-            </a:r>
-            <a:br/>
-            <a:r>
-              <a:t>Interactivity</a:t>
-            </a:r>
-          </a:p>
-        </p:txBody>
-      </p:sp>
-      <p:sp>
-        <p:nvSpPr>
-          <p:cNvPr id="22" name="TextBox 21"/>
-          <p:cNvSpPr txBox="1"/>
-          <p:nvPr/>
-        </p:nvSpPr>
-        <p:spPr>
-          <a:xfrm>
-            <a:off x="6446519" y="2103120"/>
-            <a:ext cx="2423160" cy="914400"/>
-          </a:xfrm>
-          <a:prstGeom prst="rect">
-            <a:avLst/>
-          </a:prstGeom>
-          <a:noFill/>
-        </p:spPr>
-        <p:txBody>
-          <a:bodyPr wrap="square">
-            <a:spAutoFit/>
-          </a:bodyPr>
-          <a:lstStyle/>
-          <a:p>
-            <a:pPr algn="ctr">
-              <a:defRPr sz="1300" b="0" i="0">
-                <a:solidFill>
-                  <a:srgbClr val="4A5A6A"/>
-                </a:solidFill>
-                <a:latin typeface="Calibri"/>
-              </a:defRPr>
-            </a:pPr>
-            <a:r>
-              <a:t>9 controls with instant</a:t>
-            </a:r>
-            <a:br/>
-            <a:r>
-              <a:t>updates and filtering</a:t>
-            </a:r>
-          </a:p>
-        </p:txBody>
-      </p:sp>
-      <p:sp>
-        <p:nvSpPr>
-          <p:cNvPr id="23" name="Rounded Rectangle 22"/>
-          <p:cNvSpPr/>
-          <p:nvPr/>
-        </p:nvSpPr>
-        <p:spPr>
-          <a:xfrm>
-            <a:off x="9189719" y="1325880"/>
-            <a:ext cx="2697480" cy="1965960"/>
-          </a:xfrm>
-          <a:prstGeom prst="roundRect">
-            <a:avLst/>
-          </a:prstGeom>
-          <a:solidFill>
-            <a:srgbClr val="FFFFFF"/>
-          </a:solidFill>
-          <a:ln w="9525">
-            <a:solidFill>
-              <a:srgbClr val="E0E0E0"/>
-            </a:solidFill>
-          </a:ln>
-          <a:effectLst/>
-        </p:spPr>
-        <p:style>
-          <a:lnRef idx="1">
-            <a:schemeClr val="accent1"/>
-          </a:lnRef>
-          <a:fillRef idx="3">
-            <a:schemeClr val="accent1"/>
-          </a:fillRef>
-          <a:effectRef idx="2">
-            <a:schemeClr val="accent1"/>
-          </a:effectRef>
-          <a:fontRef idx="minor">
-            <a:schemeClr val="lt1"/>
-          </a:fontRef>
-        </p:style>
-        <p:txBody>
-          <a:bodyPr rtlCol="0" anchor="ctr"/>
-          <a:lstStyle/>
-          <a:p>
-            <a:pPr algn="ctr"/>
-          </a:p>
-        </p:txBody>
-      </p:sp>
-      <p:sp>
-        <p:nvSpPr>
-          <p:cNvPr id="24" name="Rectangle 23"/>
-          <p:cNvSpPr/>
-          <p:nvPr/>
-        </p:nvSpPr>
-        <p:spPr>
-          <a:xfrm>
-            <a:off x="9189719" y="1325880"/>
-            <a:ext cx="2697480" cy="640080"/>
-          </a:xfrm>
-          <a:prstGeom prst="rect">
-            <a:avLst/>
-          </a:prstGeom>
-          <a:solidFill>
-            <a:srgbClr val="E69F00"/>
-          </a:solidFill>
-          <a:ln>
-            <a:noFill/>
-          </a:ln>
-          <a:effectLst/>
-        </p:spPr>
-        <p:style>
-          <a:lnRef idx="1">
-            <a:schemeClr val="accent1"/>
-          </a:lnRef>
-          <a:fillRef idx="3">
-            <a:schemeClr val="accent1"/>
-          </a:fillRef>
-          <a:effectRef idx="2">
-            <a:schemeClr val="accent1"/>
-          </a:effectRef>
-          <a:fontRef idx="minor">
-            <a:schemeClr val="lt1"/>
-          </a:fontRef>
-        </p:style>
-        <p:txBody>
-          <a:bodyPr rtlCol="0" anchor="ctr"/>
-          <a:lstStyle/>
-          <a:p>
-            <a:pPr algn="ctr"/>
-          </a:p>
-        </p:txBody>
-      </p:sp>
-      <p:sp>
-        <p:nvSpPr>
-          <p:cNvPr id="25" name="TextBox 24"/>
-          <p:cNvSpPr txBox="1"/>
-          <p:nvPr/>
-        </p:nvSpPr>
-        <p:spPr>
-          <a:xfrm>
-            <a:off x="9326879" y="1371600"/>
-            <a:ext cx="2423160" cy="548640"/>
-          </a:xfrm>
-          <a:prstGeom prst="rect">
-            <a:avLst/>
-          </a:prstGeom>
-          <a:noFill/>
-        </p:spPr>
-        <p:txBody>
-          <a:bodyPr wrap="square">
-            <a:spAutoFit/>
-          </a:bodyPr>
-          <a:lstStyle/>
-          <a:p>
-            <a:pPr algn="ctr">
-              <a:defRPr sz="1500" b="1" i="0">
-                <a:solidFill>
-                  <a:srgbClr val="FFFFFF"/>
-                </a:solidFill>
-                <a:latin typeface="Calibri"/>
-              </a:defRPr>
-            </a:pPr>
-            <a:r>
-              <a:t>AI</a:t>
-            </a:r>
-            <a:br/>
-            <a:r>
-              <a:t>Explanation</a:t>
-            </a:r>
-          </a:p>
-        </p:txBody>
-      </p:sp>
-      <p:sp>
-        <p:nvSpPr>
-          <p:cNvPr id="26" name="TextBox 25"/>
-          <p:cNvSpPr txBox="1"/>
-          <p:nvPr/>
-        </p:nvSpPr>
-        <p:spPr>
-          <a:xfrm>
-            <a:off x="9326879" y="2103120"/>
-            <a:ext cx="2423160" cy="914400"/>
-          </a:xfrm>
-          <a:prstGeom prst="rect">
-            <a:avLst/>
-          </a:prstGeom>
-          <a:noFill/>
-        </p:spPr>
-        <p:txBody>
-          <a:bodyPr wrap="square">
-            <a:spAutoFit/>
-          </a:bodyPr>
-          <a:lstStyle/>
-          <a:p>
-            <a:pPr algn="ctr">
-              <a:defRPr sz="1300" b="0" i="0">
-                <a:solidFill>
-                  <a:srgbClr val="4A5A6A"/>
-                </a:solidFill>
-                <a:latin typeface="Calibri"/>
-              </a:defRPr>
-            </a:pPr>
-            <a:r>
-              <a:t>Natural-language recommendation</a:t>
-            </a:r>
-            <a:br/>
-            <a:r>
-              <a:t>rationale via Qwen</a:t>
-            </a:r>
-          </a:p>
-        </p:txBody>
-      </p:sp>
-      <p:sp>
-        <p:nvSpPr>
-          <p:cNvPr id="27" name="TextBox 26"/>
-          <p:cNvSpPr txBox="1"/>
-          <p:nvPr/>
-        </p:nvSpPr>
-        <p:spPr>
-          <a:xfrm>
-            <a:off x="731520" y="3611880"/>
-            <a:ext cx="10515600" cy="320040"/>
-          </a:xfrm>
-          <a:prstGeom prst="rect">
-            <a:avLst/>
-          </a:prstGeom>
-          <a:noFill/>
-        </p:spPr>
-        <p:txBody>
-          <a:bodyPr wrap="square">
-            <a:spAutoFit/>
-          </a:bodyPr>
-          <a:lstStyle/>
-          <a:p>
-            <a:pPr algn="l">
-              <a:defRPr sz="1800" b="1" i="0">
-                <a:solidFill>
-                  <a:srgbClr val="0F3DA8"/>
-                </a:solidFill>
-                <a:latin typeface="Calibri"/>
-              </a:defRPr>
-            </a:pPr>
-            <a:r>
-              <a:t>Assignment Requirements Checklist</a:t>
-            </a:r>
-          </a:p>
-        </p:txBody>
-      </p:sp>
-      <p:sp>
-        <p:nvSpPr>
-          <p:cNvPr id="28" name="Rounded Rectangle 27"/>
-          <p:cNvSpPr/>
-          <p:nvPr/>
-        </p:nvSpPr>
-        <p:spPr>
-          <a:xfrm>
-            <a:off x="731520" y="4023360"/>
-            <a:ext cx="10728655" cy="2103120"/>
-          </a:xfrm>
-          <a:prstGeom prst="roundRect">
-            <a:avLst/>
-          </a:prstGeom>
-          <a:solidFill>
-            <a:srgbClr val="FFFFFF"/>
-          </a:solidFill>
-          <a:ln w="9525">
-            <a:solidFill>
-              <a:srgbClr val="E0E0E0"/>
-            </a:solidFill>
-          </a:ln>
-          <a:effectLst/>
-        </p:spPr>
-        <p:style>
-          <a:lnRef idx="1">
-            <a:schemeClr val="accent1"/>
-          </a:lnRef>
-          <a:fillRef idx="3">
-            <a:schemeClr val="accent1"/>
-          </a:fillRef>
-          <a:effectRef idx="2">
-            <a:schemeClr val="accent1"/>
-          </a:effectRef>
-          <a:fontRef idx="minor">
-            <a:schemeClr val="lt1"/>
-          </a:fontRef>
-        </p:style>
-        <p:txBody>
-          <a:bodyPr rtlCol="0" anchor="ctr"/>
-          <a:lstStyle/>
-          <a:p>
-            <a:pPr algn="ctr"/>
-          </a:p>
-        </p:txBody>
-      </p:sp>
-      <p:sp>
-        <p:nvSpPr>
-          <p:cNvPr id="29" name="Rounded Rectangle 28"/>
-          <p:cNvSpPr/>
-          <p:nvPr/>
-        </p:nvSpPr>
-        <p:spPr>
-          <a:xfrm>
-            <a:off x="777240" y="4114800"/>
-            <a:ext cx="10637215" cy="347472"/>
+            <a:off x="868680" y="2880360"/>
+            <a:ext cx="10454335" cy="457200"/>
           </a:xfrm>
           <a:prstGeom prst="roundRect">
             <a:avLst/>
@@ -6574,14 +5921,14 @@
       </p:sp>
       <p:sp>
         <p:nvSpPr>
-          <p:cNvPr id="30" name="TextBox 29"/>
-          <p:cNvSpPr txBox="1"/>
-          <p:nvPr/>
-        </p:nvSpPr>
-        <p:spPr>
-          <a:xfrm>
-            <a:off x="914400" y="4169664"/>
-            <a:ext cx="6400800" cy="256032"/>
+          <p:cNvPr id="15" name="TextBox 14"/>
+          <p:cNvSpPr txBox="1"/>
+          <p:nvPr/>
+        </p:nvSpPr>
+        <p:spPr>
+          <a:xfrm>
+            <a:off x="1051560" y="2962656"/>
+            <a:ext cx="6583680" cy="292608"/>
           </a:xfrm>
           <a:prstGeom prst="rect">
             <a:avLst/>
@@ -6595,7 +5942,7 @@
           <a:lstStyle/>
           <a:p>
             <a:pPr algn="l">
-              <a:defRPr sz="1200" b="0" i="0">
+              <a:defRPr sz="1500" b="0" i="0">
                 <a:solidFill>
                   <a:srgbClr val="1A1A2E"/>
                 </a:solidFill>
@@ -6610,14 +5957,14 @@
       </p:sp>
       <p:sp>
         <p:nvSpPr>
-          <p:cNvPr id="31" name="TextBox 30"/>
-          <p:cNvSpPr txBox="1"/>
-          <p:nvPr/>
-        </p:nvSpPr>
-        <p:spPr>
-          <a:xfrm>
-            <a:off x="7498079" y="4169664"/>
-            <a:ext cx="3657600" cy="256032"/>
+          <p:cNvPr id="16" name="TextBox 15"/>
+          <p:cNvSpPr txBox="1"/>
+          <p:nvPr/>
+        </p:nvSpPr>
+        <p:spPr>
+          <a:xfrm>
+            <a:off x="7863840" y="2962656"/>
+            <a:ext cx="3474720" cy="292608"/>
           </a:xfrm>
           <a:prstGeom prst="rect">
             <a:avLst/>
@@ -6631,7 +5978,7 @@
           <a:lstStyle/>
           <a:p>
             <a:pPr algn="l">
-              <a:defRPr sz="1200" b="1" i="0">
+              <a:defRPr sz="1500" b="1" i="0">
                 <a:solidFill>
                   <a:srgbClr val="2E7D32"/>
                 </a:solidFill>
@@ -6646,14 +5993,14 @@
       </p:sp>
       <p:sp>
         <p:nvSpPr>
-          <p:cNvPr id="32" name="TextBox 31"/>
-          <p:cNvSpPr txBox="1"/>
-          <p:nvPr/>
-        </p:nvSpPr>
-        <p:spPr>
-          <a:xfrm>
-            <a:off x="914400" y="4535424"/>
-            <a:ext cx="6400800" cy="256032"/>
+          <p:cNvPr id="17" name="TextBox 16"/>
+          <p:cNvSpPr txBox="1"/>
+          <p:nvPr/>
+        </p:nvSpPr>
+        <p:spPr>
+          <a:xfrm>
+            <a:off x="1051560" y="3465576"/>
+            <a:ext cx="6583680" cy="292608"/>
           </a:xfrm>
           <a:prstGeom prst="rect">
             <a:avLst/>
@@ -6667,7 +6014,7 @@
           <a:lstStyle/>
           <a:p>
             <a:pPr algn="l">
-              <a:defRPr sz="1200" b="0" i="0">
+              <a:defRPr sz="1500" b="0" i="0">
                 <a:solidFill>
                   <a:srgbClr val="1A1A2E"/>
                 </a:solidFill>
@@ -6682,14 +6029,14 @@
       </p:sp>
       <p:sp>
         <p:nvSpPr>
-          <p:cNvPr id="33" name="TextBox 32"/>
-          <p:cNvSpPr txBox="1"/>
-          <p:nvPr/>
-        </p:nvSpPr>
-        <p:spPr>
-          <a:xfrm>
-            <a:off x="7498079" y="4535424"/>
-            <a:ext cx="3657600" cy="256032"/>
+          <p:cNvPr id="18" name="TextBox 17"/>
+          <p:cNvSpPr txBox="1"/>
+          <p:nvPr/>
+        </p:nvSpPr>
+        <p:spPr>
+          <a:xfrm>
+            <a:off x="7863840" y="3465576"/>
+            <a:ext cx="3474720" cy="292608"/>
           </a:xfrm>
           <a:prstGeom prst="rect">
             <a:avLst/>
@@ -6703,7 +6050,7 @@
           <a:lstStyle/>
           <a:p>
             <a:pPr algn="l">
-              <a:defRPr sz="1200" b="1" i="0">
+              <a:defRPr sz="1500" b="1" i="0">
                 <a:solidFill>
                   <a:srgbClr val="2E7D32"/>
                 </a:solidFill>
@@ -6718,14 +6065,14 @@
       </p:sp>
       <p:sp>
         <p:nvSpPr>
-          <p:cNvPr id="34" name="Rounded Rectangle 33"/>
+          <p:cNvPr id="19" name="Rounded Rectangle 18"/>
           <p:cNvSpPr/>
           <p:nvPr/>
         </p:nvSpPr>
         <p:spPr>
           <a:xfrm>
-            <a:off x="777240" y="4846320"/>
-            <a:ext cx="10637215" cy="347472"/>
+            <a:off x="868680" y="3886200"/>
+            <a:ext cx="10454335" cy="457200"/>
           </a:xfrm>
           <a:prstGeom prst="roundRect">
             <a:avLst/>
@@ -6762,14 +6109,14 @@
       </p:sp>
       <p:sp>
         <p:nvSpPr>
-          <p:cNvPr id="35" name="TextBox 34"/>
-          <p:cNvSpPr txBox="1"/>
-          <p:nvPr/>
-        </p:nvSpPr>
-        <p:spPr>
-          <a:xfrm>
-            <a:off x="914400" y="4901184"/>
-            <a:ext cx="6400800" cy="256032"/>
+          <p:cNvPr id="20" name="TextBox 19"/>
+          <p:cNvSpPr txBox="1"/>
+          <p:nvPr/>
+        </p:nvSpPr>
+        <p:spPr>
+          <a:xfrm>
+            <a:off x="1051560" y="3968496"/>
+            <a:ext cx="6583680" cy="292608"/>
           </a:xfrm>
           <a:prstGeom prst="rect">
             <a:avLst/>
@@ -6783,7 +6130,7 @@
           <a:lstStyle/>
           <a:p>
             <a:pPr algn="l">
-              <a:defRPr sz="1200" b="0" i="0">
+              <a:defRPr sz="1500" b="0" i="0">
                 <a:solidFill>
                   <a:srgbClr val="1A1A2E"/>
                 </a:solidFill>
@@ -6798,14 +6145,14 @@
       </p:sp>
       <p:sp>
         <p:nvSpPr>
-          <p:cNvPr id="36" name="TextBox 35"/>
-          <p:cNvSpPr txBox="1"/>
-          <p:nvPr/>
-        </p:nvSpPr>
-        <p:spPr>
-          <a:xfrm>
-            <a:off x="7498079" y="4901184"/>
-            <a:ext cx="3657600" cy="256032"/>
+          <p:cNvPr id="21" name="TextBox 20"/>
+          <p:cNvSpPr txBox="1"/>
+          <p:nvPr/>
+        </p:nvSpPr>
+        <p:spPr>
+          <a:xfrm>
+            <a:off x="7863840" y="3968496"/>
+            <a:ext cx="3474720" cy="292608"/>
           </a:xfrm>
           <a:prstGeom prst="rect">
             <a:avLst/>
@@ -6819,7 +6166,7 @@
           <a:lstStyle/>
           <a:p>
             <a:pPr algn="l">
-              <a:defRPr sz="1200" b="1" i="0">
+              <a:defRPr sz="1500" b="1" i="0">
                 <a:solidFill>
                   <a:srgbClr val="2E7D32"/>
                 </a:solidFill>
@@ -6834,14 +6181,14 @@
       </p:sp>
       <p:sp>
         <p:nvSpPr>
-          <p:cNvPr id="37" name="TextBox 36"/>
-          <p:cNvSpPr txBox="1"/>
-          <p:nvPr/>
-        </p:nvSpPr>
-        <p:spPr>
-          <a:xfrm>
-            <a:off x="914400" y="5266944"/>
-            <a:ext cx="6400800" cy="256032"/>
+          <p:cNvPr id="22" name="TextBox 21"/>
+          <p:cNvSpPr txBox="1"/>
+          <p:nvPr/>
+        </p:nvSpPr>
+        <p:spPr>
+          <a:xfrm>
+            <a:off x="1051560" y="4471416"/>
+            <a:ext cx="6583680" cy="292608"/>
           </a:xfrm>
           <a:prstGeom prst="rect">
             <a:avLst/>
@@ -6855,7 +6202,7 @@
           <a:lstStyle/>
           <a:p>
             <a:pPr algn="l">
-              <a:defRPr sz="1200" b="0" i="0">
+              <a:defRPr sz="1500" b="0" i="0">
                 <a:solidFill>
                   <a:srgbClr val="1A1A2E"/>
                 </a:solidFill>
@@ -6870,14 +6217,14 @@
       </p:sp>
       <p:sp>
         <p:nvSpPr>
-          <p:cNvPr id="38" name="TextBox 37"/>
-          <p:cNvSpPr txBox="1"/>
-          <p:nvPr/>
-        </p:nvSpPr>
-        <p:spPr>
-          <a:xfrm>
-            <a:off x="7498079" y="5266944"/>
-            <a:ext cx="3657600" cy="256032"/>
+          <p:cNvPr id="23" name="TextBox 22"/>
+          <p:cNvSpPr txBox="1"/>
+          <p:nvPr/>
+        </p:nvSpPr>
+        <p:spPr>
+          <a:xfrm>
+            <a:off x="7863840" y="4471416"/>
+            <a:ext cx="3474720" cy="292608"/>
           </a:xfrm>
           <a:prstGeom prst="rect">
             <a:avLst/>
@@ -6891,7 +6238,7 @@
           <a:lstStyle/>
           <a:p>
             <a:pPr algn="l">
-              <a:defRPr sz="1200" b="1" i="0">
+              <a:defRPr sz="1500" b="1" i="0">
                 <a:solidFill>
                   <a:srgbClr val="2E7D32"/>
                 </a:solidFill>
@@ -6906,14 +6253,14 @@
       </p:sp>
       <p:sp>
         <p:nvSpPr>
-          <p:cNvPr id="39" name="Rounded Rectangle 38"/>
+          <p:cNvPr id="24" name="Rounded Rectangle 23"/>
           <p:cNvSpPr/>
           <p:nvPr/>
         </p:nvSpPr>
         <p:spPr>
           <a:xfrm>
-            <a:off x="777240" y="5577840"/>
-            <a:ext cx="10637215" cy="347472"/>
+            <a:off x="868680" y="4892040"/>
+            <a:ext cx="10454335" cy="457200"/>
           </a:xfrm>
           <a:prstGeom prst="roundRect">
             <a:avLst/>
@@ -6950,14 +6297,14 @@
       </p:sp>
       <p:sp>
         <p:nvSpPr>
-          <p:cNvPr id="40" name="TextBox 39"/>
-          <p:cNvSpPr txBox="1"/>
-          <p:nvPr/>
-        </p:nvSpPr>
-        <p:spPr>
-          <a:xfrm>
-            <a:off x="914400" y="5632704"/>
-            <a:ext cx="6400800" cy="256032"/>
+          <p:cNvPr id="25" name="TextBox 24"/>
+          <p:cNvSpPr txBox="1"/>
+          <p:nvPr/>
+        </p:nvSpPr>
+        <p:spPr>
+          <a:xfrm>
+            <a:off x="1051560" y="4974336"/>
+            <a:ext cx="6583680" cy="292608"/>
           </a:xfrm>
           <a:prstGeom prst="rect">
             <a:avLst/>
@@ -6971,7 +6318,7 @@
           <a:lstStyle/>
           <a:p>
             <a:pPr algn="l">
-              <a:defRPr sz="1200" b="0" i="0">
+              <a:defRPr sz="1500" b="0" i="0">
                 <a:solidFill>
                   <a:srgbClr val="1A1A2E"/>
                 </a:solidFill>
@@ -6986,14 +6333,14 @@
       </p:sp>
       <p:sp>
         <p:nvSpPr>
-          <p:cNvPr id="41" name="TextBox 40"/>
-          <p:cNvSpPr txBox="1"/>
-          <p:nvPr/>
-        </p:nvSpPr>
-        <p:spPr>
-          <a:xfrm>
-            <a:off x="7498079" y="5632704"/>
-            <a:ext cx="3657600" cy="256032"/>
+          <p:cNvPr id="26" name="TextBox 25"/>
+          <p:cNvSpPr txBox="1"/>
+          <p:nvPr/>
+        </p:nvSpPr>
+        <p:spPr>
+          <a:xfrm>
+            <a:off x="7863840" y="4974336"/>
+            <a:ext cx="3474720" cy="292608"/>
           </a:xfrm>
           <a:prstGeom prst="rect">
             <a:avLst/>
@@ -7007,7 +6354,7 @@
           <a:lstStyle/>
           <a:p>
             <a:pPr algn="l">
-              <a:defRPr sz="1200" b="1" i="0">
+              <a:defRPr sz="1500" b="1" i="0">
                 <a:solidFill>
                   <a:srgbClr val="2E7D32"/>
                 </a:solidFill>
@@ -7016,6 +6363,78 @@
             </a:pPr>
             <a:r>
               <a:t>✅ Fully runnable end-to-end</a:t>
+            </a:r>
+          </a:p>
+        </p:txBody>
+      </p:sp>
+      <p:sp>
+        <p:nvSpPr>
+          <p:cNvPr id="27" name="TextBox 26"/>
+          <p:cNvSpPr txBox="1"/>
+          <p:nvPr/>
+        </p:nvSpPr>
+        <p:spPr>
+          <a:xfrm>
+            <a:off x="1051560" y="5477256"/>
+            <a:ext cx="6583680" cy="292608"/>
+          </a:xfrm>
+          <a:prstGeom prst="rect">
+            <a:avLst/>
+          </a:prstGeom>
+          <a:noFill/>
+        </p:spPr>
+        <p:txBody>
+          <a:bodyPr wrap="square">
+            <a:spAutoFit/>
+          </a:bodyPr>
+          <a:lstStyle/>
+          <a:p>
+            <a:pPr algn="l">
+              <a:defRPr sz="1500" b="0" i="0">
+                <a:solidFill>
+                  <a:srgbClr val="1A1A2E"/>
+                </a:solidFill>
+                <a:latin typeface="Calibri"/>
+              </a:defRPr>
+            </a:pPr>
+            <a:r>
+              <a:t>LLM-assisted decision support (live)</a:t>
+            </a:r>
+          </a:p>
+        </p:txBody>
+      </p:sp>
+      <p:sp>
+        <p:nvSpPr>
+          <p:cNvPr id="28" name="TextBox 27"/>
+          <p:cNvSpPr txBox="1"/>
+          <p:nvPr/>
+        </p:nvSpPr>
+        <p:spPr>
+          <a:xfrm>
+            <a:off x="7863840" y="5477256"/>
+            <a:ext cx="3474720" cy="292608"/>
+          </a:xfrm>
+          <a:prstGeom prst="rect">
+            <a:avLst/>
+          </a:prstGeom>
+          <a:noFill/>
+        </p:spPr>
+        <p:txBody>
+          <a:bodyPr wrap="square">
+            <a:spAutoFit/>
+          </a:bodyPr>
+          <a:lstStyle/>
+          <a:p>
+            <a:pPr algn="l">
+              <a:defRPr sz="1500" b="1" i="0">
+                <a:solidFill>
+                  <a:srgbClr val="2E7D32"/>
+                </a:solidFill>
+                <a:latin typeface="Calibri"/>
+              </a:defRPr>
+            </a:pPr>
+            <a:r>
+              <a:t>✅ Qwen analysis verified working</a:t>
             </a:r>
           </a:p>
         </p:txBody>

</xml_diff>

<commit_message>
Add timed speaker script to slide notes and a Word presentation guide
- Inject a per-slide timed script into every slide's presenter notes
- Add Presentation_Guide.docx: setup checklist, slide-by-slide flow,
  live-demo steps, and Q&A prep
</commit_message>
<xml_diff>
--- a/Final_Project_Presentation.pptx
+++ b/Final_Project_Presentation.pptx
@@ -514,33 +514,7 @@
           <a:lstStyle/>
           <a:p>
             <a:r>
-              <a:t>PRESENTER NOTES – Title Slide</a:t>
-            </a:r>
-          </a:p>
-          <a:p/>
-          <a:p>
-            <a:r>
-              <a:t>Good morning/afternoon, professors and classmates.</a:t>
-            </a:r>
-          </a:p>
-          <a:p>
-            <a:r>
-              <a:t>My name is Painda Mohammad Fayaz, Student ID 22511204.</a:t>
-            </a:r>
-          </a:p>
-          <a:p>
-            <a:r>
-              <a:t>Today I will present my final project for the LLM-Assisted Intelligent Decision Application course.</a:t>
-            </a:r>
-          </a:p>
-          <a:p>
-            <a:r>
-              <a:t>My project is an LLM-Powered Intelligent Job Matching System that combines rule-based scoring with Qwen to help HR teams match candidates to job postings.</a:t>
-            </a:r>
-          </a:p>
-          <a:p>
-            <a:r>
-              <a:t>The presentation will take approximately 10 minutes, followed by 5 minutes of Q&amp;A.</a:t>
+              <a:t>[0:15]  Good morning. I'm Painda Mohammad Fayaz, student 22511204. My final project is an LLM-powered intelligent job-matching system that helps HR teams match candidates to job openings.</a:t>
             </a:r>
           </a:p>
         </p:txBody>
@@ -610,30 +584,7 @@
           <a:lstStyle/>
           <a:p>
             <a:r>
-              <a:t>PRESENTER NOTES – Results &amp; Capabilities</a:t>
-            </a:r>
-          </a:p>
-          <a:p/>
-          <a:p>
-            <a:r>
-              <a:t>To summarize, here is how the project maps to each official requirement.</a:t>
-            </a:r>
-          </a:p>
-          <a:p>
-            <a:r>
-              <a:t>(Frame this as a recap, not self-grading.)</a:t>
-            </a:r>
-          </a:p>
-          <a:p/>
-          <a:p>
-            <a:r>
-              <a:t>Every requirement is met: complete input-&gt;analysis-&gt;display-&gt;recommendation pipeline, Python + Jupyter Notebook, all required libraries (pandas, matplotlib, scikit-learn, ipywidgets), all four modules with 9 interactive controls, fully runnable end-to-end, and a live LLM (Qwen) analysis I verified is working.</a:t>
-            </a:r>
-          </a:p>
-          <a:p/>
-          <a:p>
-            <a:r>
-              <a:t>Pause on the last row — the live Qwen call is the core deliverable and it runs in the demo.</a:t>
+              <a:t>[0:45]  To summarize, here's how the project maps to each official requirement -- complete input-analysis-display-recommendation pipeline, Python + Jupyter, all required libraries, four modules with nine controls, fully runnable, and a verified live Qwen analysis. Say it as a RECAP, not self-grading.</a:t>
             </a:r>
           </a:p>
         </p:txBody>
@@ -703,39 +654,7 @@
           <a:lstStyle/>
           <a:p>
             <a:r>
-              <a:t>PRESENTER NOTES – Limitations &amp; Future Work</a:t>
-            </a:r>
-          </a:p>
-          <a:p/>
-          <a:p>
-            <a:r>
-              <a:t>Limitations:</a:t>
-            </a:r>
-          </a:p>
-          <a:p>
-            <a:r>
-              <a:t>1. Term matching – TF-IDF gives partial credit but not true synonyms (React ≈ Vue). Solution: embeddings.</a:t>
-            </a:r>
-          </a:p>
-          <a:p>
-            <a:r>
-              <a:t>2. Synthetic sample – 1,070 jobs, 153 candidates, all generated. Needs real databases.</a:t>
-            </a:r>
-          </a:p>
-          <a:p>
-            <a:r>
-              <a:t>3. LLM latency – 2–5 sec per call. Could cache common combinations.</a:t>
-            </a:r>
-          </a:p>
-          <a:p>
-            <a:r>
-              <a:t>4. No learning loop – doesn’t improve from HR feedback.</a:t>
-            </a:r>
-          </a:p>
-          <a:p/>
-          <a:p>
-            <a:r>
-              <a:t>Future work: semantic embeddings, resume parsing, bidirectional matching, RL from feedback, multi-model voting.</a:t>
+              <a:t>[0:45]  Honestly, there are limits. The dataset is synthetic. Skill matching is term-level -- TF-IDF gives partial credit but not true synonyms; embeddings would fix that. Each LLM call needs internet and takes a few seconds; caching would help. And there's no feedback loop yet -- HR ratings could tune the weights.</a:t>
             </a:r>
           </a:p>
         </p:txBody>
@@ -805,37 +724,7 @@
           <a:lstStyle/>
           <a:p>
             <a:r>
-              <a:t>PRESENTER NOTES – Summary</a:t>
-            </a:r>
-          </a:p>
-          <a:p/>
-          <a:p>
-            <a:r>
-              <a:t>Three key takeaways:</a:t>
-            </a:r>
-          </a:p>
-          <a:p/>
-          <a:p>
-            <a:r>
-              <a:t>1. Hybrid rule + LLM architecture is the right approach for decision-support. Rules give auditability; LLM gives semantic understanding.</a:t>
-            </a:r>
-          </a:p>
-          <a:p/>
-          <a:p>
-            <a:r>
-              <a:t>2. Full-stack implementation covering data input, analysis, visualization, and AI recommendations with Jupyter and web interfaces.</a:t>
-            </a:r>
-          </a:p>
-          <a:p/>
-          <a:p>
-            <a:r>
-              <a:t>3. LLM used throughout the entire lifecycle — design through optimization. Runtime prompt engineered for structured output.</a:t>
-            </a:r>
-          </a:p>
-          <a:p/>
-          <a:p>
-            <a:r>
-              <a:t>Thank you for your attention. I’m happy to answer any questions.</a:t>
+              <a:t>[0:30]  In summary: combining rule-based scoring with an LLM gives both transparency and intelligence. The result is fast, explainable, interactive job matching.</a:t>
             </a:r>
           </a:p>
         </p:txBody>
@@ -905,55 +794,32 @@
           <a:lstStyle/>
           <a:p>
             <a:r>
-              <a:t>PRESENTER NOTES – Thank You &amp; Q&amp;A</a:t>
-            </a:r>
-          </a:p>
-          <a:p/>
-          <a:p>
-            <a:r>
-              <a:t>Thank you for your attention!</a:t>
-            </a:r>
-          </a:p>
-          <a:p>
-            <a:r>
-              <a:t>I’m happy to answer any questions about the system architecture, the scoring algorithm, the LLM integration, or the demo.</a:t>
-            </a:r>
-          </a:p>
-          <a:p/>
-          <a:p>
-            <a:r>
-              <a:t>To try the system:</a:t>
-            </a:r>
-          </a:p>
-          <a:p>
-            <a:r>
-              <a:t>1. Clone the project folder</a:t>
-            </a:r>
-          </a:p>
-          <a:p>
-            <a:r>
-              <a:t>2. pip install -r requirements.txt</a:t>
-            </a:r>
-          </a:p>
-          <a:p>
-            <a:r>
-              <a:t>3. Add your DashScope API key to .env</a:t>
-            </a:r>
-          </a:p>
-          <a:p>
-            <a:r>
-              <a:t>4. jupyter notebook job_matching.ipynb</a:t>
-            </a:r>
-          </a:p>
-          <a:p>
-            <a:r>
-              <a:t>5. Or: python app.py (web interface at localhost:5000)</a:t>
-            </a:r>
-          </a:p>
-          <a:p/>
-          <a:p>
-            <a:r>
-              <a:t>Contact: fayazpainda@mail.dlut.edu.cn</a:t>
+              <a:t>[Q&amp;A ~5:00]  Thank you -- I'm happy to take questions.</a:t>
+            </a:r>
+          </a:p>
+          <a:p>
+            <a:r>
+              <a:t>LIKELY QUESTIONS:</a:t>
+            </a:r>
+          </a:p>
+          <a:p>
+            <a:r>
+              <a:t>- Where is scikit-learn? -&gt; in skill_match_score (cell 6): TF-IDF vectorizer + cosine similarity.</a:t>
+            </a:r>
+          </a:p>
+          <a:p>
+            <a:r>
+              <a:t>- Which model / is it really live? -&gt; qwen-plus via DashScope, OpenAI-compatible; yes, a live API call -- I can run it again.</a:t>
+            </a:r>
+          </a:p>
+          <a:p>
+            <a:r>
+              <a:t>- Why not pure LLM? -&gt; a black box, slow, costs per call; rules give auditable scores, the LLM only adds explanation.</a:t>
+            </a:r>
+          </a:p>
+          <a:p>
+            <a:r>
+              <a:t>- Weaknesses? -&gt; synthetic data and term-level matching; embeddings are the next step.</a:t>
             </a:r>
           </a:p>
         </p:txBody>
@@ -1023,28 +889,7 @@
           <a:lstStyle/>
           <a:p>
             <a:r>
-              <a:t>PRESENTER NOTES – Outline</a:t>
-            </a:r>
-          </a:p>
-          <a:p/>
-          <a:p>
-            <a:r>
-              <a:t>Here is the roadmap for today’s presentation.</a:t>
-            </a:r>
-          </a:p>
-          <a:p>
-            <a:r>
-              <a:t>I will start with the problem background, explain the difficulties in current recruiting processes, then walk through my solution architecture including the scoring algorithm and LLM integration.</a:t>
-            </a:r>
-          </a:p>
-          <a:p>
-            <a:r>
-              <a:t>After that, I’ll show a live demo and discuss results, limitations, and future improvements.</a:t>
-            </a:r>
-          </a:p>
-          <a:p>
-            <a:r>
-              <a:t>Let’s begin with the problem background.</a:t>
+              <a:t>[0:15]  Here's my outline: the problem and its difficulties, my solution design, how I use the LLM, a live demo, and finally results and limitations.</a:t>
             </a:r>
           </a:p>
         </p:txBody>
@@ -1114,28 +959,7 @@
           <a:lstStyle/>
           <a:p>
             <a:r>
-              <a:t>PRESENTER NOTES – Problem Background</a:t>
-            </a:r>
-          </a:p>
-          <a:p/>
-          <a:p>
-            <a:r>
-              <a:t>The scenario is straightforward: HR teams in tech companies receive hundreds of resumes and need to match them against open job postings.</a:t>
-            </a:r>
-          </a:p>
-          <a:p>
-            <a:r>
-              <a:t>Currently, each resume takes 5–10 minutes to manually compare against job requirements.</a:t>
-            </a:r>
-          </a:p>
-          <a:p>
-            <a:r>
-              <a:t>Our dataset covers 1,070 jobs across major tech companies like Google, Meta, Amazon, OpenAI, and Anthropic, with 153 candidate profiles spanning backend, frontend, AI/ML, and DevOps roles.</a:t>
-            </a:r>
-          </a:p>
-          <a:p>
-            <a:r>
-              <a:t>The system scores candidates across 4 dimensions: skills, experience, education, and location.</a:t>
+              <a:t>[0:45]  The scenario is tech-company recruiting. HR teams must match many candidates to many job postings, and today it's done manually -- reading each resume and comparing it to the job requirements. My users are HR staff and job seekers; the goal is fast, explainable matches.</a:t>
             </a:r>
           </a:p>
         </p:txBody>
@@ -1205,38 +1029,7 @@
           <a:lstStyle/>
           <a:p>
             <a:r>
-              <a:t>PRESENTER NOTES – Current Difficulties</a:t>
-            </a:r>
-          </a:p>
-          <a:p/>
-          <a:p>
-            <a:r>
-              <a:t>There are four main pain points in traditional recruiting:</a:t>
-            </a:r>
-          </a:p>
-          <a:p>
-            <a:r>
-              <a:t>1. Low efficiency – manual review takes 5–10 min per resume, doesn’t scale.</a:t>
-            </a:r>
-          </a:p>
-          <a:p>
-            <a:r>
-              <a:t>2. Subjective scoring – different HR people, different criteria, inconsistent.</a:t>
-            </a:r>
-          </a:p>
-          <a:p>
-            <a:r>
-              <a:t>3. Black-box rejections – ATS gives a score but no explanation.</a:t>
-            </a:r>
-          </a:p>
-          <a:p>
-            <a:r>
-              <a:t>4. Multi-dimensional tradeoffs – skills, experience, education, location all matter differently per role.</a:t>
-            </a:r>
-          </a:p>
-          <a:p>
-            <a:r>
-              <a:t>These problems motivate our hybrid rule + LLM approach.</a:t>
+              <a:t>[0:45]  There are four pain points. It's SLOW -- 5 to 10 minutes per resume. It's SUBJECTIVE -- different reviewers judge differently. Traditional systems are a BLACK BOX -- one score, no reason. And the right weighting of skills, experience, education and location differs for every role.</a:t>
             </a:r>
           </a:p>
         </p:txBody>
@@ -1306,39 +1099,7 @@
           <a:lstStyle/>
           <a:p>
             <a:r>
-              <a:t>PRESENTER NOTES – Solution Architecture</a:t>
-            </a:r>
-          </a:p>
-          <a:p/>
-          <a:p>
-            <a:r>
-              <a:t>Our solution uses a two-layer combination:</a:t>
-            </a:r>
-          </a:p>
-          <a:p>
-            <a:r>
-              <a:t>Layer 1: Rule-based scoring computes a weighted composite across 4 dimensions.</a:t>
-            </a:r>
-          </a:p>
-          <a:p>
-            <a:r>
-              <a:t>Layer 2: LLM (Qwen) generates natural-language explanations for the top match.</a:t>
-            </a:r>
-          </a:p>
-          <a:p/>
-          <a:p>
-            <a:r>
-              <a:t>Why not pure rules? Transparent but rigid — can’t understand semantic similarity.</a:t>
-            </a:r>
-          </a:p>
-          <a:p>
-            <a:r>
-              <a:t>Why not pure LLM? Flexible but opaque, expensive, unreliable.</a:t>
-            </a:r>
-          </a:p>
-          <a:p>
-            <a:r>
-              <a:t>Our hybrid gives auditable quantitative scores plus human-readable AI insights.</a:t>
+              <a:t>[1:00]  My design is a two-layer hybrid. First, a transparent rule-based engine scores every candidate-job pair on four weighted dimensions. Then the LLM adds a natural-language explanation for the top match. Rules give auditability; the LLM adds semantic understanding. Neither alone is enough -- pure rules are rigid, pure LLM is a costly black box.</a:t>
             </a:r>
           </a:p>
         </p:txBody>
@@ -1408,45 +1169,7 @@
           <a:lstStyle/>
           <a:p>
             <a:r>
-              <a:t>PRESENTER NOTES – Scoring Algorithm</a:t>
-            </a:r>
-          </a:p>
-          <a:p/>
-          <a:p>
-            <a:r>
-              <a:t>Each candidate–job pair is scored on four dimensions, normalized to 0–1:</a:t>
-            </a:r>
-          </a:p>
-          <a:p/>
-          <a:p>
-            <a:r>
-              <a:t>1. Skills Match (50%): hybrid score = exact keyword overlap, with a scikit-learn TF-IDF + cosine-similarity term filling the gap so related stacks earn partial credit.</a:t>
-            </a:r>
-          </a:p>
-          <a:p>
-            <a:r>
-              <a:t>2. Experience (20%): full score if meets minimum years; proportional otherwise.</a:t>
-            </a:r>
-          </a:p>
-          <a:p>
-            <a:r>
-              <a:t>3. Education (15%): maps degrees to numeric levels.</a:t>
-            </a:r>
-          </a:p>
-          <a:p>
-            <a:r>
-              <a:t>4. Location (15%): exact=1.0, remote=0.7, different city=0.3.</a:t>
-            </a:r>
-          </a:p>
-          <a:p/>
-          <a:p>
-            <a:r>
-              <a:t>The 0.3 for location mismatch was suggested by Qwen to preserve remote options.</a:t>
-            </a:r>
-          </a:p>
-          <a:p>
-            <a:r>
-              <a:t>All weights are user-adjustable and auto-normalized to sum to 1.</a:t>
+              <a:t>[1:00]  Each pair is scored 0 to 100 across four dimensions -- skills, experience, education, location -- with adjustable weights. The skills score is a HYBRID: exact keyword overlap PLUS a scikit-learn TF-IDF cosine-similarity term, so related tech stacks earn partial credit. Experience and education are proportional; location rewards an exact or remote match.</a:t>
             </a:r>
           </a:p>
         </p:txBody>
@@ -1516,59 +1239,7 @@
           <a:lstStyle/>
           <a:p>
             <a:r>
-              <a:t>PRESENTER NOTES – LLM Integration</a:t>
-            </a:r>
-          </a:p>
-          <a:p/>
-          <a:p>
-            <a:r>
-              <a:t>Qwen is used throughout the project lifecycle, not just at runtime:</a:t>
-            </a:r>
-          </a:p>
-          <a:p>
-            <a:r>
-              <a:t>- Design: decomposed into input/analysis/display/recommendation modules</a:t>
-            </a:r>
-          </a:p>
-          <a:p>
-            <a:r>
-              <a:t>- Code generation: ipywidgets UI and matplotlib charts</a:t>
-            </a:r>
-          </a:p>
-          <a:p>
-            <a:r>
-              <a:t>- Debugging: font display, weight normalization, CSV parsing</a:t>
-            </a:r>
-          </a:p>
-          <a:p>
-            <a:r>
-              <a:t>- Runtime core feature: natural-language match analysis</a:t>
-            </a:r>
-          </a:p>
-          <a:p>
-            <a:r>
-              <a:t>- Optimization: suggested 0.3 location score</a:t>
-            </a:r>
-          </a:p>
-          <a:p/>
-          <a:p>
-            <a:r>
-              <a:t>The runtime prompt is carefully designed:</a:t>
-            </a:r>
-          </a:p>
-          <a:p>
-            <a:r>
-              <a:t>- Role: ‘experienced HR consultant’</a:t>
-            </a:r>
-          </a:p>
-          <a:p>
-            <a:r>
-              <a:t>- Structured 3-section output: highlights, gaps, recommendation</a:t>
-            </a:r>
-          </a:p>
-          <a:p>
-            <a:r>
-              <a:t>- max_tokens=600 for cost control (~$0.15 total)</a:t>
+              <a:t>[0:45]  I use Qwen -- Alibaba's model -- through an OpenAI-compatible API. After the rules rank the jobs, I send the top match and its scores to Qwen, which returns a structured analysis: Highlights, Gaps, and a Recommendation. The LLM also helped me during development -- module design, UI code generation, and debugging.</a:t>
             </a:r>
           </a:p>
         </p:txBody>
@@ -1638,29 +1309,17 @@
           <a:lstStyle/>
           <a:p>
             <a:r>
-              <a:t>PRESENTER NOTES – Interactive Interface</a:t>
-            </a:r>
-          </a:p>
-          <a:p/>
-          <a:p>
-            <a:r>
-              <a:t>Two interfaces:</a:t>
-            </a:r>
-          </a:p>
-          <a:p>
-            <a:r>
-              <a:t>1. Jupyter Notebook (primary): 9 interactive controls for candidate selection, weight adjustment, location filter, salary filter, and LLM toggle.</a:t>
-            </a:r>
-          </a:p>
-          <a:p>
-            <a:r>
-              <a:t>2. Flask Web App (alternative): modern web UI on localhost:5000 with AJAX-powered real-time matching.</a:t>
-            </a:r>
-          </a:p>
-          <a:p/>
-          <a:p>
-            <a:r>
-              <a:t>Tech stack: Python (pandas, numpy, scikit-learn, matplotlib), Qwen (DashScope) API, ipywidgets + Flask.</a:t>
+              <a:t>[0:30]  &gt;&gt;&gt; DEMO HANDOFF &lt;&lt;&lt;</a:t>
+            </a:r>
+          </a:p>
+          <a:p>
+            <a:r>
+              <a:t>The whole thing runs in a Jupyter Notebook with ipywidgets. Rather than describe it, let me show it live.</a:t>
+            </a:r>
+          </a:p>
+          <a:p>
+            <a:r>
+              <a:t>ACTION: press Cmd+Tab to the notebook. Confirm 'Qwen API ready: model=qwen-plus' is visible at the top.</a:t>
             </a:r>
           </a:p>
         </p:txBody>
@@ -1730,49 +1389,42 @@
           <a:lstStyle/>
           <a:p>
             <a:r>
-              <a:t>PRESENTER NOTES – Live Demo Walkthrough</a:t>
-            </a:r>
-          </a:p>
-          <a:p/>
-          <a:p>
-            <a:r>
-              <a:t>6-step demo flow (3–4 minutes):</a:t>
-            </a:r>
-          </a:p>
-          <a:p>
-            <a:r>
-              <a:t>1. Pick Alex Johnson – Python backend, 5 years.</a:t>
-            </a:r>
-          </a:p>
-          <a:p>
-            <a:r>
-              <a:t>2. Default weights – Senior Python Backend Engineer at ~90 score.</a:t>
-            </a:r>
-          </a:p>
-          <a:p>
-            <a:r>
-              <a:t>3. Raise Location weight – location-matched jobs rise.</a:t>
-            </a:r>
-          </a:p>
-          <a:p>
-            <a:r>
-              <a:t>4. Filter to San Francisco – live filtering.</a:t>
-            </a:r>
-          </a:p>
-          <a:p>
-            <a:r>
-              <a:t>5. Show Qwen analysis – highlights/gaps/recommendation.</a:t>
-            </a:r>
-          </a:p>
-          <a:p>
-            <a:r>
-              <a:t>6. Switch to Harper Scott – top results change to LLM roles.</a:t>
-            </a:r>
-          </a:p>
-          <a:p/>
-          <a:p>
-            <a:r>
-              <a:t>This showcases scoring, weight adjustment, filtering, visualization, and LLM analysis.</a:t>
+              <a:t>[~3:00]  &gt;&gt;&gt; LIVE DEMO -- the most important part &lt;&lt;&lt;</a:t>
+            </a:r>
+          </a:p>
+          <a:p>
+            <a:r>
+              <a:t>1) Pick a candidate from the dropdown.</a:t>
+            </a:r>
+          </a:p>
+          <a:p>
+            <a:r>
+              <a:t>2) Click MATCH -- show the Top-5 table and the 4-dimension bar charts.</a:t>
+            </a:r>
+          </a:p>
+          <a:p>
+            <a:r>
+              <a:t>3) Drag the LOCATION weight up -- the ranking updates live.</a:t>
+            </a:r>
+          </a:p>
+          <a:p>
+            <a:r>
+              <a:t>4) Scroll to the QWEN ANALYSIS -- read the Highlights / Gaps / Recommendation, and stress that this is a LIVE LLM call.</a:t>
+            </a:r>
+          </a:p>
+          <a:p>
+            <a:r>
+              <a:t>5) (Optional) switch candidate to show the top match adapts.</a:t>
+            </a:r>
+          </a:p>
+          <a:p>
+            <a:r>
+              <a:t>Then press Cmd+Tab back to PowerPoint.</a:t>
+            </a:r>
+          </a:p>
+          <a:p>
+            <a:r>
+              <a:t>If the network fails: stay calm, show the llm_explain_match cell and the prompt.</a:t>
             </a:r>
           </a:p>
         </p:txBody>

</xml_diff>